<commit_message>
Added Final PPT Combined
</commit_message>
<xml_diff>
--- a/Reports/ViT_Distillation_MinorityClass.pptx
+++ b/Reports/ViT_Distillation_MinorityClass.pptx
@@ -15,8 +15,8 @@
     <p:sldId id="260" r:id="rId6"/>
     <p:sldId id="261" r:id="rId7"/>
     <p:sldId id="262" r:id="rId8"/>
-    <p:sldId id="263" r:id="rId9"/>
-    <p:sldId id="264" r:id="rId10"/>
+    <p:sldId id="285" r:id="rId9"/>
+    <p:sldId id="286" r:id="rId10"/>
     <p:sldId id="265" r:id="rId11"/>
     <p:sldId id="266" r:id="rId12"/>
     <p:sldId id="267" r:id="rId13"/>
@@ -183,115 +183,115 @@
               <c:strCache>
                 <c:ptCount val="37"/>
                 <c:pt idx="0">
-                  <c:v>c0</c:v>
+                  <c:v>Abyssinian_cat</c:v>
                 </c:pt>
                 <c:pt idx="1">
-                  <c:v>c1</c:v>
+                  <c:v>american_bulldog_dog</c:v>
                 </c:pt>
                 <c:pt idx="2">
-                  <c:v>c2</c:v>
+                  <c:v>american_pit_bull_terrier_dog</c:v>
                 </c:pt>
                 <c:pt idx="3">
-                  <c:v>c3</c:v>
+                  <c:v>basset_hound_dog</c:v>
                 </c:pt>
                 <c:pt idx="4">
-                  <c:v>c4</c:v>
+                  <c:v>beagle_dog</c:v>
                 </c:pt>
                 <c:pt idx="5">
-                  <c:v>c5</c:v>
+                  <c:v>Bengal_cat</c:v>
                 </c:pt>
                 <c:pt idx="6">
-                  <c:v>c6</c:v>
+                  <c:v>Birman_cat</c:v>
                 </c:pt>
                 <c:pt idx="7">
-                  <c:v>c7</c:v>
+                  <c:v>Bombay_cat</c:v>
                 </c:pt>
                 <c:pt idx="8">
-                  <c:v>c8</c:v>
+                  <c:v>boxer_dog</c:v>
                 </c:pt>
                 <c:pt idx="9">
-                  <c:v>c9</c:v>
+                  <c:v>British_Shorthair_cat</c:v>
                 </c:pt>
                 <c:pt idx="10">
-                  <c:v>c10</c:v>
+                  <c:v>chihuahua_dog</c:v>
                 </c:pt>
                 <c:pt idx="11">
-                  <c:v>c11</c:v>
+                  <c:v>Egyptian_Mau_cat</c:v>
                 </c:pt>
                 <c:pt idx="12">
-                  <c:v>c12</c:v>
+                  <c:v>english_cocker_spaniel_dog</c:v>
                 </c:pt>
                 <c:pt idx="13">
-                  <c:v>c13</c:v>
+                  <c:v>english_setter_dog</c:v>
                 </c:pt>
                 <c:pt idx="14">
-                  <c:v>c14</c:v>
+                  <c:v>german_shorthaired_dog</c:v>
                 </c:pt>
                 <c:pt idx="15">
-                  <c:v>c15</c:v>
+                  <c:v>great_pyrenees_dog</c:v>
                 </c:pt>
                 <c:pt idx="16">
-                  <c:v>c16</c:v>
+                  <c:v>havanese_dog</c:v>
                 </c:pt>
                 <c:pt idx="17">
-                  <c:v>c17</c:v>
+                  <c:v>japanese_chin_dog</c:v>
                 </c:pt>
                 <c:pt idx="18">
-                  <c:v>c18</c:v>
+                  <c:v>keeshond_dog</c:v>
                 </c:pt>
                 <c:pt idx="19">
-                  <c:v>c19</c:v>
+                  <c:v>leonberger_dog</c:v>
                 </c:pt>
                 <c:pt idx="20">
-                  <c:v>c20</c:v>
+                  <c:v>Maine_Coon_cat</c:v>
                 </c:pt>
                 <c:pt idx="21">
-                  <c:v>c21</c:v>
+                  <c:v>miniature_pinscher_dog</c:v>
                 </c:pt>
                 <c:pt idx="22">
-                  <c:v>c22</c:v>
+                  <c:v>newfoundland_dog</c:v>
                 </c:pt>
                 <c:pt idx="23">
-                  <c:v>c23</c:v>
+                  <c:v>Persian_cat</c:v>
                 </c:pt>
                 <c:pt idx="24">
-                  <c:v>c24</c:v>
+                  <c:v>pomeranian_dog</c:v>
                 </c:pt>
                 <c:pt idx="25">
-                  <c:v>c25</c:v>
+                  <c:v>pug_dog</c:v>
                 </c:pt>
                 <c:pt idx="26">
-                  <c:v>c26</c:v>
+                  <c:v>Ragdoll_cat</c:v>
                 </c:pt>
                 <c:pt idx="27">
-                  <c:v>c27</c:v>
+                  <c:v>Russian_Blue_cat</c:v>
                 </c:pt>
                 <c:pt idx="28">
-                  <c:v>c28</c:v>
+                  <c:v>saint_bernard_dog</c:v>
                 </c:pt>
                 <c:pt idx="29">
-                  <c:v>c29</c:v>
+                  <c:v>samoyed_dog</c:v>
                 </c:pt>
                 <c:pt idx="30">
-                  <c:v>c30</c:v>
+                  <c:v>scottish_terrier_dog</c:v>
                 </c:pt>
                 <c:pt idx="31">
-                  <c:v>c31</c:v>
+                  <c:v>shiba_inu_dog</c:v>
                 </c:pt>
                 <c:pt idx="32">
-                  <c:v>c32</c:v>
+                  <c:v>Siamese_cat</c:v>
                 </c:pt>
                 <c:pt idx="33">
-                  <c:v>c33</c:v>
+                  <c:v>Sphynx_cat</c:v>
                 </c:pt>
                 <c:pt idx="34">
-                  <c:v>c34</c:v>
+                  <c:v>staffordshire_bull_terrier_dog</c:v>
                 </c:pt>
                 <c:pt idx="35">
-                  <c:v>c35</c:v>
+                  <c:v>wheaten_terrier_dog</c:v>
                 </c:pt>
                 <c:pt idx="36">
-                  <c:v>c36</c:v>
+                  <c:v>yorkshire_terrier_dog</c:v>
                 </c:pt>
               </c:strCache>
             </c:strRef>
@@ -470,115 +470,115 @@
               <c:strCache>
                 <c:ptCount val="37"/>
                 <c:pt idx="0">
-                  <c:v>c0</c:v>
+                  <c:v>Abyssinian_cat</c:v>
                 </c:pt>
                 <c:pt idx="1">
-                  <c:v>c1</c:v>
+                  <c:v>american_bulldog_dog</c:v>
                 </c:pt>
                 <c:pt idx="2">
-                  <c:v>c2</c:v>
+                  <c:v>american_pit_bull_terrier_dog</c:v>
                 </c:pt>
                 <c:pt idx="3">
-                  <c:v>c3</c:v>
+                  <c:v>basset_hound_dog</c:v>
                 </c:pt>
                 <c:pt idx="4">
-                  <c:v>c4</c:v>
+                  <c:v>beagle_dog</c:v>
                 </c:pt>
                 <c:pt idx="5">
-                  <c:v>c5</c:v>
+                  <c:v>Bengal_cat</c:v>
                 </c:pt>
                 <c:pt idx="6">
-                  <c:v>c6</c:v>
+                  <c:v>Birman_cat</c:v>
                 </c:pt>
                 <c:pt idx="7">
-                  <c:v>c7</c:v>
+                  <c:v>Bombay_cat</c:v>
                 </c:pt>
                 <c:pt idx="8">
-                  <c:v>c8</c:v>
+                  <c:v>boxer_dog</c:v>
                 </c:pt>
                 <c:pt idx="9">
-                  <c:v>c9</c:v>
+                  <c:v>British_Shorthair_cat</c:v>
                 </c:pt>
                 <c:pt idx="10">
-                  <c:v>c10</c:v>
+                  <c:v>chihuahua_dog</c:v>
                 </c:pt>
                 <c:pt idx="11">
-                  <c:v>c11</c:v>
+                  <c:v>Egyptian_Mau_cat</c:v>
                 </c:pt>
                 <c:pt idx="12">
-                  <c:v>c12</c:v>
+                  <c:v>english_cocker_spaniel_dog</c:v>
                 </c:pt>
                 <c:pt idx="13">
-                  <c:v>c13</c:v>
+                  <c:v>english_setter_dog</c:v>
                 </c:pt>
                 <c:pt idx="14">
-                  <c:v>c14</c:v>
+                  <c:v>german_shorthaired_dog</c:v>
                 </c:pt>
                 <c:pt idx="15">
-                  <c:v>c15</c:v>
+                  <c:v>great_pyrenees_dog</c:v>
                 </c:pt>
                 <c:pt idx="16">
-                  <c:v>c16</c:v>
+                  <c:v>havanese_dog</c:v>
                 </c:pt>
                 <c:pt idx="17">
-                  <c:v>c17</c:v>
+                  <c:v>japanese_chin_dog</c:v>
                 </c:pt>
                 <c:pt idx="18">
-                  <c:v>c18</c:v>
+                  <c:v>keeshond_dog</c:v>
                 </c:pt>
                 <c:pt idx="19">
-                  <c:v>c19</c:v>
+                  <c:v>leonberger_dog</c:v>
                 </c:pt>
                 <c:pt idx="20">
-                  <c:v>c20</c:v>
+                  <c:v>Maine_Coon_cat</c:v>
                 </c:pt>
                 <c:pt idx="21">
-                  <c:v>c21</c:v>
+                  <c:v>miniature_pinscher_dog</c:v>
                 </c:pt>
                 <c:pt idx="22">
-                  <c:v>c22</c:v>
+                  <c:v>newfoundland_dog</c:v>
                 </c:pt>
                 <c:pt idx="23">
-                  <c:v>c23</c:v>
+                  <c:v>Persian_cat</c:v>
                 </c:pt>
                 <c:pt idx="24">
-                  <c:v>c24</c:v>
+                  <c:v>pomeranian_dog</c:v>
                 </c:pt>
                 <c:pt idx="25">
-                  <c:v>c25</c:v>
+                  <c:v>pug_dog</c:v>
                 </c:pt>
                 <c:pt idx="26">
-                  <c:v>c26</c:v>
+                  <c:v>Ragdoll_cat</c:v>
                 </c:pt>
                 <c:pt idx="27">
-                  <c:v>c27</c:v>
+                  <c:v>Russian_Blue_cat</c:v>
                 </c:pt>
                 <c:pt idx="28">
-                  <c:v>c28</c:v>
+                  <c:v>saint_bernard_dog</c:v>
                 </c:pt>
                 <c:pt idx="29">
-                  <c:v>c29</c:v>
+                  <c:v>samoyed_dog</c:v>
                 </c:pt>
                 <c:pt idx="30">
-                  <c:v>c30</c:v>
+                  <c:v>scottish_terrier_dog</c:v>
                 </c:pt>
                 <c:pt idx="31">
-                  <c:v>c31</c:v>
+                  <c:v>shiba_inu_dog</c:v>
                 </c:pt>
                 <c:pt idx="32">
-                  <c:v>c32</c:v>
+                  <c:v>Siamese_cat</c:v>
                 </c:pt>
                 <c:pt idx="33">
-                  <c:v>c33</c:v>
+                  <c:v>Sphynx_cat</c:v>
                 </c:pt>
                 <c:pt idx="34">
-                  <c:v>c34</c:v>
+                  <c:v>staffordshire_bull_terrier_dog</c:v>
                 </c:pt>
                 <c:pt idx="35">
-                  <c:v>c35</c:v>
+                  <c:v>wheaten_terrier_dog</c:v>
                 </c:pt>
                 <c:pt idx="36">
-                  <c:v>c36</c:v>
+                  <c:v>yorkshire_terrier_dog</c:v>
                 </c:pt>
               </c:strCache>
             </c:strRef>
@@ -748,7 +748,7 @@
           <a:lstStyle/>
           <a:p>
             <a:pPr>
-              <a:defRPr sz="1200" b="0" i="0" u="none" strike="noStrike">
+              <a:defRPr sz="1100" b="0" i="0" u="none" strike="noStrike">
                 <a:solidFill>
                   <a:srgbClr val="64748B"/>
                 </a:solidFill>
@@ -936,40 +936,40 @@
               <c:strCache>
                 <c:ptCount val="12"/>
                 <c:pt idx="0">
-                  <c:v>c0</c:v>
+                  <c:v>Abyssinian_cat</c:v>
                 </c:pt>
                 <c:pt idx="1">
-                  <c:v>c1</c:v>
+                  <c:v>Bengal_cat</c:v>
                 </c:pt>
                 <c:pt idx="2">
-                  <c:v>c2</c:v>
+                  <c:v>Birman_cat</c:v>
                 </c:pt>
                 <c:pt idx="3">
-                  <c:v>c3</c:v>
+                  <c:v>Bombay_cat</c:v>
                 </c:pt>
                 <c:pt idx="4">
-                  <c:v>c4</c:v>
+                  <c:v>British_Shorthair_cat</c:v>
                 </c:pt>
                 <c:pt idx="5">
-                  <c:v>c5</c:v>
+                  <c:v>Egyptian_Mau_cat</c:v>
                 </c:pt>
                 <c:pt idx="6">
-                  <c:v>c6</c:v>
+                  <c:v>Maine_Coon_cat</c:v>
                 </c:pt>
                 <c:pt idx="7">
-                  <c:v>c7</c:v>
+                  <c:v>Persian_cat</c:v>
                 </c:pt>
                 <c:pt idx="8">
-                  <c:v>c8</c:v>
+                  <c:v>Ragdoll_cat</c:v>
                 </c:pt>
                 <c:pt idx="9">
-                  <c:v>c9</c:v>
+                  <c:v>Russian_Blue_cat</c:v>
                 </c:pt>
                 <c:pt idx="10">
-                  <c:v>c10</c:v>
+                  <c:v>Siamese_cat</c:v>
                 </c:pt>
                 <c:pt idx="11">
-                  <c:v>c11</c:v>
+                  <c:v>Sphynx_cat</c:v>
                 </c:pt>
               </c:strCache>
             </c:strRef>
@@ -981,40 +981,40 @@
                 <c:formatCode>General</c:formatCode>
                 <c:ptCount val="12"/>
                 <c:pt idx="0">
-                  <c:v>0.158</c:v>
+                  <c:v>0.157999999999999</c:v>
                 </c:pt>
                 <c:pt idx="1">
-                  <c:v>1.6E-2</c:v>
+                  <c:v>9.0999999999999998E-2</c:v>
                 </c:pt>
                 <c:pt idx="2">
-                  <c:v>0.11600000000000001</c:v>
+                  <c:v>0.103999999999999</c:v>
                 </c:pt>
                 <c:pt idx="3">
+                  <c:v>4.39999999999999E-2</c:v>
+                </c:pt>
+                <c:pt idx="4">
+                  <c:v>0.112999999999999</c:v>
+                </c:pt>
+                <c:pt idx="5">
+                  <c:v>9.7999999999999907E-2</c:v>
+                </c:pt>
+                <c:pt idx="6">
                   <c:v>5.6000000000000001E-2</c:v>
                 </c:pt>
-                <c:pt idx="4">
-                  <c:v>5.8000000000000003E-2</c:v>
-                </c:pt>
-                <c:pt idx="5">
-                  <c:v>9.0999999999999998E-2</c:v>
-                </c:pt>
-                <c:pt idx="6">
-                  <c:v>0.104</c:v>
-                </c:pt>
                 <c:pt idx="7">
-                  <c:v>4.3999999999999997E-2</c:v>
+                  <c:v>3.6999999999999998E-2</c:v>
                 </c:pt>
                 <c:pt idx="8">
-                  <c:v>0.104</c:v>
+                  <c:v>0.17799999999999999</c:v>
                 </c:pt>
                 <c:pt idx="9">
-                  <c:v>0.113</c:v>
+                  <c:v>0.129</c:v>
                 </c:pt>
                 <c:pt idx="10">
-                  <c:v>4.7E-2</c:v>
+                  <c:v>1.2E-2</c:v>
                 </c:pt>
                 <c:pt idx="11">
-                  <c:v>9.8000000000000004E-2</c:v>
+                  <c:v>0.104999999999999</c:v>
                 </c:pt>
               </c:numCache>
             </c:numRef>
@@ -1062,7 +1062,7 @@
           <a:lstStyle/>
           <a:p>
             <a:pPr>
-              <a:defRPr sz="1200" b="0" i="0" u="none" strike="noStrike">
+              <a:defRPr sz="800" b="0" i="0" u="none" strike="noStrike">
                 <a:solidFill>
                   <a:srgbClr val="64748B"/>
                 </a:solidFill>
@@ -1250,79 +1250,79 @@
               <c:strCache>
                 <c:ptCount val="25"/>
                 <c:pt idx="0">
-                  <c:v>c12</c:v>
+                  <c:v>american_bulldog_dog</c:v>
                 </c:pt>
                 <c:pt idx="1">
-                  <c:v>c13</c:v>
+                  <c:v>american_pit_bull_terrier_dog</c:v>
                 </c:pt>
                 <c:pt idx="2">
-                  <c:v>c14</c:v>
+                  <c:v>basset_hound_dog</c:v>
                 </c:pt>
                 <c:pt idx="3">
-                  <c:v>c15</c:v>
+                  <c:v>beagle_dog</c:v>
                 </c:pt>
                 <c:pt idx="4">
-                  <c:v>c16</c:v>
+                  <c:v>boxer_dog</c:v>
                 </c:pt>
                 <c:pt idx="5">
-                  <c:v>c17</c:v>
+                  <c:v>chihuahua_dog</c:v>
                 </c:pt>
                 <c:pt idx="6">
-                  <c:v>c18</c:v>
+                  <c:v>english_cocker_spaniel_dog</c:v>
                 </c:pt>
                 <c:pt idx="7">
-                  <c:v>c19</c:v>
+                  <c:v>english_setter_dog</c:v>
                 </c:pt>
                 <c:pt idx="8">
-                  <c:v>c20</c:v>
+                  <c:v>german_shorthaired_dog</c:v>
                 </c:pt>
                 <c:pt idx="9">
-                  <c:v>c21</c:v>
+                  <c:v>great_pyrenees_dog</c:v>
                 </c:pt>
                 <c:pt idx="10">
-                  <c:v>c22</c:v>
+                  <c:v>havanese_dog</c:v>
                 </c:pt>
                 <c:pt idx="11">
-                  <c:v>c23</c:v>
+                  <c:v>japanese_chin_dog</c:v>
                 </c:pt>
                 <c:pt idx="12">
-                  <c:v>c24</c:v>
+                  <c:v>keeshond_dog</c:v>
                 </c:pt>
                 <c:pt idx="13">
-                  <c:v>c25</c:v>
+                  <c:v>leonberger_dog</c:v>
                 </c:pt>
                 <c:pt idx="14">
-                  <c:v>c26</c:v>
+                  <c:v>miniature_pinscher_dog</c:v>
                 </c:pt>
                 <c:pt idx="15">
-                  <c:v>c27</c:v>
+                  <c:v>newfoundland_dog</c:v>
                 </c:pt>
                 <c:pt idx="16">
-                  <c:v>c28</c:v>
+                  <c:v>pomeranian_dog</c:v>
                 </c:pt>
                 <c:pt idx="17">
-                  <c:v>c29</c:v>
+                  <c:v>pug_dog</c:v>
                 </c:pt>
                 <c:pt idx="18">
-                  <c:v>c30</c:v>
+                  <c:v>saint_bernard_dog</c:v>
                 </c:pt>
                 <c:pt idx="19">
-                  <c:v>c31</c:v>
+                  <c:v>samoyed_dog</c:v>
                 </c:pt>
                 <c:pt idx="20">
-                  <c:v>c32</c:v>
+                  <c:v>scottish_terrier_dog</c:v>
                 </c:pt>
                 <c:pt idx="21">
-                  <c:v>c33</c:v>
+                  <c:v>shiba_inu_dog</c:v>
                 </c:pt>
                 <c:pt idx="22">
-                  <c:v>c34</c:v>
+                  <c:v>staffordshire_bull_terrier_dog</c:v>
                 </c:pt>
                 <c:pt idx="23">
-                  <c:v>c35</c:v>
+                  <c:v>wheaten_terrier_dog</c:v>
                 </c:pt>
                 <c:pt idx="24">
-                  <c:v>c36</c:v>
+                  <c:v>yorkshire_terrier_dog</c:v>
                 </c:pt>
               </c:strCache>
             </c:strRef>
@@ -1334,79 +1334,79 @@
                 <c:formatCode>General</c:formatCode>
                 <c:ptCount val="25"/>
                 <c:pt idx="0">
+                  <c:v>1.6E-2</c:v>
+                </c:pt>
+                <c:pt idx="1">
+                  <c:v>0.11599999999999901</c:v>
+                </c:pt>
+                <c:pt idx="2">
+                  <c:v>5.6000000000000001E-2</c:v>
+                </c:pt>
+                <c:pt idx="3">
+                  <c:v>5.7999999999999899E-2</c:v>
+                </c:pt>
+                <c:pt idx="4">
+                  <c:v>0.103999999999999</c:v>
+                </c:pt>
+                <c:pt idx="5">
+                  <c:v>4.6999999999999903E-2</c:v>
+                </c:pt>
+                <c:pt idx="6">
                   <c:v>7.0000000000000007E-2</c:v>
                 </c:pt>
-                <c:pt idx="1">
-                  <c:v>8.3000000000000004E-2</c:v>
-                </c:pt>
-                <c:pt idx="2">
+                <c:pt idx="7">
+                  <c:v>8.2999999999999893E-2</c:v>
+                </c:pt>
+                <c:pt idx="8">
                   <c:v>5.0000000000000001E-3</c:v>
                 </c:pt>
-                <c:pt idx="3">
+                <c:pt idx="9">
                   <c:v>1.9E-2</c:v>
                 </c:pt>
-                <c:pt idx="4">
+                <c:pt idx="10">
                   <c:v>6.2E-2</c:v>
                 </c:pt>
-                <c:pt idx="5">
+                <c:pt idx="11">
                   <c:v>5.3999999999999999E-2</c:v>
                 </c:pt>
-                <c:pt idx="6">
+                <c:pt idx="12">
+                  <c:v>3.7999999999999902E-2</c:v>
+                </c:pt>
+                <c:pt idx="13">
+                  <c:v>3.1999999999999897E-2</c:v>
+                </c:pt>
+                <c:pt idx="14">
+                  <c:v>3.2000000000000001E-2</c:v>
+                </c:pt>
+                <c:pt idx="15">
+                  <c:v>0.02</c:v>
+                </c:pt>
+                <c:pt idx="16">
+                  <c:v>1.6E-2</c:v>
+                </c:pt>
+                <c:pt idx="17">
+                  <c:v>1.9E-2</c:v>
+                </c:pt>
+                <c:pt idx="18">
+                  <c:v>6.4000000000000001E-2</c:v>
+                </c:pt>
+                <c:pt idx="19">
+                  <c:v>4.0000000000000001E-3</c:v>
+                </c:pt>
+                <c:pt idx="20">
+                  <c:v>4.5999999999999999E-2</c:v>
+                </c:pt>
+                <c:pt idx="21">
                   <c:v>3.7999999999999999E-2</c:v>
                 </c:pt>
-                <c:pt idx="7">
-                  <c:v>3.2000000000000001E-2</c:v>
-                </c:pt>
-                <c:pt idx="8">
-                  <c:v>5.6000000000000001E-2</c:v>
-                </c:pt>
-                <c:pt idx="9">
-                  <c:v>3.2000000000000001E-2</c:v>
-                </c:pt>
-                <c:pt idx="10">
-                  <c:v>0.02</c:v>
-                </c:pt>
-                <c:pt idx="11">
-                  <c:v>3.6999999999999998E-2</c:v>
-                </c:pt>
-                <c:pt idx="12">
-                  <c:v>1.6E-2</c:v>
-                </c:pt>
-                <c:pt idx="13">
-                  <c:v>1.9E-2</c:v>
-                </c:pt>
-                <c:pt idx="14">
-                  <c:v>0.17799999999999999</c:v>
-                </c:pt>
-                <c:pt idx="15">
-                  <c:v>0.129</c:v>
-                </c:pt>
-                <c:pt idx="16">
-                  <c:v>6.4000000000000001E-2</c:v>
-                </c:pt>
-                <c:pt idx="17">
-                  <c:v>4.0000000000000001E-3</c:v>
-                </c:pt>
-                <c:pt idx="18">
-                  <c:v>4.5999999999999999E-2</c:v>
-                </c:pt>
-                <c:pt idx="19">
-                  <c:v>3.7999999999999999E-2</c:v>
-                </c:pt>
-                <c:pt idx="20">
-                  <c:v>1.2E-2</c:v>
-                </c:pt>
-                <c:pt idx="21">
-                  <c:v>0.105</c:v>
-                </c:pt>
                 <c:pt idx="22">
-                  <c:v>5.1999999999999998E-2</c:v>
+                  <c:v>5.19999999999999E-2</c:v>
                 </c:pt>
                 <c:pt idx="23">
                   <c:v>3.5000000000000003E-2</c:v>
                 </c:pt>
                 <c:pt idx="24">
-                  <c:v>5.5E-2</c:v>
+                  <c:v>5.4999999999999903E-2</c:v>
                 </c:pt>
               </c:numCache>
             </c:numRef>
@@ -1454,7 +1454,7 @@
           <a:lstStyle/>
           <a:p>
             <a:pPr>
-              <a:defRPr sz="1200" b="0" i="0" u="none" strike="noStrike">
+              <a:defRPr sz="800" b="0" i="0" u="none" strike="noStrike">
                 <a:solidFill>
                   <a:srgbClr val="64748B"/>
                 </a:solidFill>
@@ -7550,7 +7550,7 @@
                 <a:ea typeface="Calibri" pitchFamily="34" charset="-122"/>
                 <a:cs typeface="Calibri" pitchFamily="34" charset="-120"/>
               </a:rPr>
-              <a:t>0.721</a:t>
+              <a:t>0.711</a:t>
             </a:r>
             <a:endParaRPr lang="en-US" sz="1800" dirty="0"/>
           </a:p>
@@ -7706,7 +7706,7 @@
                 <a:ea typeface="Calibri" pitchFamily="34" charset="-122"/>
                 <a:cs typeface="Calibri" pitchFamily="34" charset="-120"/>
               </a:rPr>
-              <a:t>+0.084</a:t>
+              <a:t>+0.094</a:t>
             </a:r>
             <a:endParaRPr lang="en-US" sz="1800" dirty="0"/>
           </a:p>
@@ -7965,7 +7965,7 @@
                 <a:ea typeface="Calibri" pitchFamily="34" charset="-122"/>
                 <a:cs typeface="Calibri" pitchFamily="34" charset="-120"/>
               </a:rPr>
-              <a:t>0.823</a:t>
+              <a:t>0.828</a:t>
             </a:r>
             <a:endParaRPr lang="en-US" sz="1800" dirty="0"/>
           </a:p>
@@ -8121,7 +8121,7 @@
                 <a:ea typeface="Calibri" pitchFamily="34" charset="-122"/>
                 <a:cs typeface="Calibri" pitchFamily="34" charset="-120"/>
               </a:rPr>
-              <a:t>+0.051</a:t>
+              <a:t>+0.046</a:t>
             </a:r>
             <a:endParaRPr lang="en-US" sz="1800" dirty="0"/>
           </a:p>
@@ -8209,112 +8209,6 @@
               <a:t>Highest: c26 (+0.178) c27 (+0.129) c33 (+0.105)</a:t>
             </a:r>
             <a:endParaRPr lang="en-US" sz="1000" dirty="0"/>
-          </a:p>
-        </p:txBody>
-      </p:sp>
-      <p:sp>
-        <p:nvSpPr>
-          <p:cNvPr id="25" name="Shape 23"/>
-          <p:cNvSpPr/>
-          <p:nvPr/>
-        </p:nvSpPr>
-        <p:spPr>
-          <a:xfrm>
-            <a:off x="320040" y="4069080"/>
-            <a:ext cx="8366760" cy="841248"/>
-          </a:xfrm>
-          <a:prstGeom prst="rect">
-            <a:avLst/>
-          </a:prstGeom>
-          <a:solidFill>
-            <a:srgbClr val="F5F3FF"/>
-          </a:solidFill>
-          <a:ln w="10160">
-            <a:solidFill>
-              <a:srgbClr val="7C3AED"/>
-            </a:solidFill>
-            <a:prstDash val="solid"/>
-          </a:ln>
-        </p:spPr>
-      </p:sp>
-      <p:sp>
-        <p:nvSpPr>
-          <p:cNvPr id="26" name="Text 24"/>
-          <p:cNvSpPr/>
-          <p:nvPr/>
-        </p:nvSpPr>
-        <p:spPr>
-          <a:xfrm>
-            <a:off x="475488" y="4160520"/>
-            <a:ext cx="1280160" cy="502920"/>
-          </a:xfrm>
-          <a:prstGeom prst="rect">
-            <a:avLst/>
-          </a:prstGeom>
-          <a:noFill/>
-          <a:ln/>
-        </p:spPr>
-        <p:txBody>
-          <a:bodyPr wrap="square" lIns="0" tIns="0" rIns="0" bIns="0" rtlCol="0" anchor="ctr"/>
-          <a:lstStyle/>
-          <a:p>
-            <a:pPr marL="0" indent="0">
-              <a:buNone/>
-            </a:pPr>
-            <a:r>
-              <a:rPr lang="en-US" sz="2600" b="1" dirty="0">
-                <a:solidFill>
-                  <a:srgbClr val="7C3AED"/>
-                </a:solidFill>
-                <a:latin typeface="Calibri" pitchFamily="34" charset="0"/>
-                <a:ea typeface="Calibri" pitchFamily="34" charset="-122"/>
-                <a:cs typeface="Calibri" pitchFamily="34" charset="-120"/>
-              </a:rPr>
-              <a:t>1.65×</a:t>
-            </a:r>
-            <a:endParaRPr lang="en-US" sz="2600" dirty="0"/>
-          </a:p>
-        </p:txBody>
-      </p:sp>
-      <p:sp>
-        <p:nvSpPr>
-          <p:cNvPr id="27" name="Text 25"/>
-          <p:cNvSpPr/>
-          <p:nvPr/>
-        </p:nvSpPr>
-        <p:spPr>
-          <a:xfrm>
-            <a:off x="1828800" y="4187952"/>
-            <a:ext cx="6675120" cy="658368"/>
-          </a:xfrm>
-          <a:prstGeom prst="rect">
-            <a:avLst/>
-          </a:prstGeom>
-          <a:noFill/>
-          <a:ln/>
-        </p:spPr>
-        <p:txBody>
-          <a:bodyPr wrap="square" rtlCol="0" anchor="ctr"/>
-          <a:lstStyle/>
-          <a:p>
-            <a:pPr marL="0" indent="0">
-              <a:lnSpc>
-                <a:spcPct val="130000"/>
-              </a:lnSpc>
-              <a:buNone/>
-            </a:pPr>
-            <a:r>
-              <a:rPr lang="en-US" sz="1100" dirty="0">
-                <a:solidFill>
-                  <a:srgbClr val="1E2B38"/>
-                </a:solidFill>
-                <a:latin typeface="Calibri Light" pitchFamily="34" charset="0"/>
-                <a:ea typeface="Calibri Light" pitchFamily="34" charset="-122"/>
-                <a:cs typeface="Calibri Light" pitchFamily="34" charset="-120"/>
-              </a:rPr>
-              <a:t>more gain on cat classes than dog classes — confirming the teacher's full-data minority knowledge transfers preferentially to underrepresented classes. The teacher's soft labels act as a data augmentation for breeds the student rarely saw during training.</a:t>
-            </a:r>
-            <a:endParaRPr lang="en-US" sz="1100" dirty="0"/>
           </a:p>
         </p:txBody>
       </p:sp>
@@ -8328,15 +8222,7 @@
 
 <file path=ppt/slides/slide8.xml><?xml version="1.0" encoding="utf-8"?>
 <p:sld xmlns:a="http://schemas.openxmlformats.org/drawingml/2006/main" xmlns:r="http://schemas.openxmlformats.org/officeDocument/2006/relationships" xmlns:p="http://schemas.openxmlformats.org/presentationml/2006/main">
-  <p:cSld name="Slide 8">
-    <p:bg>
-      <p:bgPr>
-        <a:solidFill>
-          <a:srgbClr val="F7FBFD"/>
-        </a:solidFill>
-        <a:effectLst/>
-      </p:bgPr>
-    </p:bg>
+  <p:cSld>
     <p:spTree>
       <p:nvGrpSpPr>
         <p:cNvPr id="1" name=""/>
@@ -8544,15 +8430,7 @@
 
 <file path=ppt/slides/slide9.xml><?xml version="1.0" encoding="utf-8"?>
 <p:sld xmlns:a="http://schemas.openxmlformats.org/drawingml/2006/main" xmlns:r="http://schemas.openxmlformats.org/officeDocument/2006/relationships" xmlns:p="http://schemas.openxmlformats.org/presentationml/2006/main">
-  <p:cSld name="Slide 9">
-    <p:bg>
-      <p:bgPr>
-        <a:solidFill>
-          <a:srgbClr val="F7FBFD"/>
-        </a:solidFill>
-        <a:effectLst/>
-      </p:bgPr>
-    </p:bg>
+  <p:cSld>
     <p:spTree>
       <p:nvGrpSpPr>
         <p:cNvPr id="1" name=""/>
@@ -8610,13 +8488,7 @@
         <p:nvGraphicFramePr>
           <p:cNvPr id="3" name="Chart 0"/>
           <p:cNvGraphicFramePr/>
-          <p:nvPr>
-            <p:extLst>
-              <p:ext uri="{D42A27DB-BD31-4B8C-83A1-F6EECF244321}">
-                <p14:modId xmlns:p14="http://schemas.microsoft.com/office/powerpoint/2010/main" val="1813400466"/>
-              </p:ext>
-            </p:extLst>
-          </p:nvPr>
+          <p:nvPr/>
         </p:nvGraphicFramePr>
         <p:xfrm>
           <a:off x="320040" y="822960"/>
@@ -8702,7 +8574,7 @@
                 <a:ea typeface="Calibri Light" pitchFamily="34" charset="-122"/>
                 <a:cs typeface="Calibri Light" pitchFamily="34" charset="-120"/>
               </a:rPr>
-              <a:t>Mean gain = +0.084   (range +0.016 to +0.158)</a:t>
+              <a:t>Mean gain = +0.094 </a:t>
             </a:r>
             <a:endParaRPr lang="en-US" sz="1000" dirty="0"/>
           </a:p>
@@ -8766,7 +8638,7 @@
                 <a:ea typeface="Calibri Light" pitchFamily="34" charset="-122"/>
                 <a:cs typeface="Calibri Light" pitchFamily="34" charset="-120"/>
               </a:rPr>
-              <a:t>Mean gain = +0.051   (range +0.004 to +0.178)</a:t>
+              <a:t>Mean gain = +0.046</a:t>
             </a:r>
             <a:endParaRPr lang="en-US" sz="1000" dirty="0"/>
           </a:p>
@@ -8896,7 +8768,7 @@
               <a:buNone/>
             </a:pPr>
             <a:r>
-              <a:rPr lang="en-US" sz="950" dirty="0">
+              <a:rPr lang="en-US" sz="1100" dirty="0">
                 <a:solidFill>
                   <a:srgbClr val="1E2B38"/>
                 </a:solidFill>
@@ -8904,9 +8776,9 @@
                 <a:ea typeface="Calibri Light" pitchFamily="34" charset="-122"/>
                 <a:cs typeface="Calibri Light" pitchFamily="34" charset="-120"/>
               </a:rPr>
-              <a:t>Class 0: +0.158</a:t>
-            </a:r>
-            <a:endParaRPr lang="en-US" sz="950" dirty="0"/>
+              <a:t>Class Ragdoll Cat: +0.178</a:t>
+            </a:r>
+            <a:endParaRPr lang="en-US" sz="1100" dirty="0"/>
           </a:p>
           <a:p>
             <a:pPr marL="0" indent="0">
@@ -8916,7 +8788,7 @@
               <a:buNone/>
             </a:pPr>
             <a:r>
-              <a:rPr lang="en-US" sz="950" dirty="0">
+              <a:rPr lang="en-US" sz="1100" dirty="0">
                 <a:solidFill>
                   <a:srgbClr val="1E2B38"/>
                 </a:solidFill>
@@ -8924,9 +8796,9 @@
                 <a:ea typeface="Calibri Light" pitchFamily="34" charset="-122"/>
                 <a:cs typeface="Calibri Light" pitchFamily="34" charset="-120"/>
               </a:rPr>
-              <a:t>direct 0.685 → distil 0.843</a:t>
-            </a:r>
-            <a:endParaRPr lang="en-US" sz="950" dirty="0"/>
+              <a:t>direct 0.503 → distil 0. 681</a:t>
+            </a:r>
+            <a:endParaRPr lang="en-US" sz="1100" dirty="0"/>
           </a:p>
         </p:txBody>
       </p:sp>
@@ -8938,7 +8810,7 @@
         </p:nvSpPr>
         <p:spPr>
           <a:xfrm>
-            <a:off x="2514600" y="4187952"/>
+            <a:off x="3794760" y="4197096"/>
             <a:ext cx="2011680" cy="694944"/>
           </a:xfrm>
           <a:prstGeom prst="rect">
@@ -8951,14 +8823,13 @@
           <a:bodyPr wrap="square" rtlCol="0" anchor="ctr"/>
           <a:lstStyle/>
           <a:p>
-            <a:pPr marL="0" indent="0">
+            <a:pPr>
               <a:lnSpc>
                 <a:spcPct val="130000"/>
               </a:lnSpc>
-              <a:buNone/>
-            </a:pPr>
-            <a:r>
-              <a:rPr lang="en-US" sz="950" dirty="0">
+            </a:pPr>
+            <a:r>
+              <a:rPr lang="en-US" sz="1100" dirty="0">
                 <a:solidFill>
                   <a:srgbClr val="1E2B38"/>
                 </a:solidFill>
@@ -8966,9 +8837,31 @@
                 <a:ea typeface="Calibri Light" pitchFamily="34" charset="-122"/>
                 <a:cs typeface="Calibri Light" pitchFamily="34" charset="-120"/>
               </a:rPr>
-              <a:t>Class 2: +0.116</a:t>
-            </a:r>
-            <a:endParaRPr lang="en-US" sz="950" dirty="0"/>
+              <a:t>Class </a:t>
+            </a:r>
+            <a:r>
+              <a:rPr lang="en-IN" sz="1100" dirty="0">
+                <a:solidFill>
+                  <a:srgbClr val="1E2B38"/>
+                </a:solidFill>
+                <a:latin typeface="Calibri Light" pitchFamily="34" charset="0"/>
+                <a:ea typeface="Calibri Light" pitchFamily="34" charset="-122"/>
+                <a:cs typeface="Calibri Light" pitchFamily="34" charset="-120"/>
+              </a:rPr>
+              <a:t>Abyssinian cat</a:t>
+            </a:r>
+            <a:r>
+              <a:rPr lang="en-US" sz="1100" dirty="0">
+                <a:solidFill>
+                  <a:srgbClr val="1E2B38"/>
+                </a:solidFill>
+                <a:latin typeface="Calibri Light" pitchFamily="34" charset="0"/>
+                <a:ea typeface="Calibri Light" pitchFamily="34" charset="-122"/>
+                <a:cs typeface="Calibri Light" pitchFamily="34" charset="-120"/>
+              </a:rPr>
+              <a:t>: +0.158</a:t>
+            </a:r>
+            <a:endParaRPr lang="en-US" sz="1100" dirty="0"/>
           </a:p>
           <a:p>
             <a:pPr marL="0" indent="0">
@@ -8978,7 +8871,7 @@
               <a:buNone/>
             </a:pPr>
             <a:r>
-              <a:rPr lang="en-US" sz="950" dirty="0">
+              <a:rPr lang="en-US" sz="1100" dirty="0">
                 <a:solidFill>
                   <a:srgbClr val="1E2B38"/>
                 </a:solidFill>
@@ -8986,9 +8879,9 @@
                 <a:ea typeface="Calibri Light" pitchFamily="34" charset="-122"/>
                 <a:cs typeface="Calibri Light" pitchFamily="34" charset="-120"/>
               </a:rPr>
-              <a:t>direct 0.506 → distil 0.622</a:t>
-            </a:r>
-            <a:endParaRPr lang="en-US" sz="950" dirty="0"/>
+              <a:t>direct 0.685 → distil 0.843</a:t>
+            </a:r>
+            <a:endParaRPr lang="en-US" sz="1100" dirty="0"/>
           </a:p>
         </p:txBody>
       </p:sp>
@@ -9000,7 +8893,7 @@
         </p:nvSpPr>
         <p:spPr>
           <a:xfrm>
-            <a:off x="4617720" y="4187952"/>
+            <a:off x="6812280" y="4206240"/>
             <a:ext cx="2011680" cy="694944"/>
           </a:xfrm>
           <a:prstGeom prst="rect">
@@ -9020,7 +8913,7 @@
               <a:buNone/>
             </a:pPr>
             <a:r>
-              <a:rPr lang="en-US" sz="950" dirty="0">
+              <a:rPr lang="en-US" sz="1100" dirty="0">
                 <a:solidFill>
                   <a:srgbClr val="1E2B38"/>
                 </a:solidFill>
@@ -9028,9 +8921,9 @@
                 <a:ea typeface="Calibri Light" pitchFamily="34" charset="-122"/>
                 <a:cs typeface="Calibri Light" pitchFamily="34" charset="-120"/>
               </a:rPr>
-              <a:t>Class 9: +0.114</a:t>
-            </a:r>
-            <a:endParaRPr lang="en-US" sz="950" dirty="0"/>
+              <a:t>Class Russian Blue cat: +0.129</a:t>
+            </a:r>
+            <a:endParaRPr lang="en-US" sz="1100" dirty="0"/>
           </a:p>
           <a:p>
             <a:pPr marL="0" indent="0">
@@ -9040,7 +8933,7 @@
               <a:buNone/>
             </a:pPr>
             <a:r>
-              <a:rPr lang="en-US" sz="950" dirty="0">
+              <a:rPr lang="en-US" sz="1100" dirty="0">
                 <a:solidFill>
                   <a:srgbClr val="1E2B38"/>
                 </a:solidFill>
@@ -9048,71 +8941,9 @@
                 <a:ea typeface="Calibri Light" pitchFamily="34" charset="-122"/>
                 <a:cs typeface="Calibri Light" pitchFamily="34" charset="-120"/>
               </a:rPr>
-              <a:t>direct 0.704 → distil 0.817</a:t>
-            </a:r>
-            <a:endParaRPr lang="en-US" sz="950" dirty="0"/>
-          </a:p>
-        </p:txBody>
-      </p:sp>
-      <p:sp>
-        <p:nvSpPr>
-          <p:cNvPr id="15" name="Text 11"/>
-          <p:cNvSpPr/>
-          <p:nvPr/>
-        </p:nvSpPr>
-        <p:spPr>
-          <a:xfrm>
-            <a:off x="6720840" y="4187952"/>
-            <a:ext cx="2011680" cy="694944"/>
-          </a:xfrm>
-          <a:prstGeom prst="rect">
-            <a:avLst/>
-          </a:prstGeom>
-          <a:noFill/>
-          <a:ln/>
-        </p:spPr>
-        <p:txBody>
-          <a:bodyPr wrap="square" rtlCol="0" anchor="ctr"/>
-          <a:lstStyle/>
-          <a:p>
-            <a:pPr marL="0" indent="0">
-              <a:lnSpc>
-                <a:spcPct val="130000"/>
-              </a:lnSpc>
-              <a:buNone/>
-            </a:pPr>
-            <a:r>
-              <a:rPr lang="en-US" sz="950" dirty="0">
-                <a:solidFill>
-                  <a:srgbClr val="1E2B38"/>
-                </a:solidFill>
-                <a:latin typeface="Calibri Light" pitchFamily="34" charset="0"/>
-                <a:ea typeface="Calibri Light" pitchFamily="34" charset="-122"/>
-                <a:cs typeface="Calibri Light" pitchFamily="34" charset="-120"/>
-              </a:rPr>
-              <a:t>Class 26: +0.178</a:t>
-            </a:r>
-            <a:endParaRPr lang="en-US" sz="950" dirty="0"/>
-          </a:p>
-          <a:p>
-            <a:pPr marL="0" indent="0">
-              <a:lnSpc>
-                <a:spcPct val="130000"/>
-              </a:lnSpc>
-              <a:buNone/>
-            </a:pPr>
-            <a:r>
-              <a:rPr lang="en-US" sz="950" dirty="0">
-                <a:solidFill>
-                  <a:srgbClr val="1E2B38"/>
-                </a:solidFill>
-                <a:latin typeface="Calibri Light" pitchFamily="34" charset="0"/>
-                <a:ea typeface="Calibri Light" pitchFamily="34" charset="-122"/>
-                <a:cs typeface="Calibri Light" pitchFamily="34" charset="-120"/>
-              </a:rPr>
-              <a:t>direct 0.503 → distil 0.681  (largest overall gain)</a:t>
-            </a:r>
-            <a:endParaRPr lang="en-US" sz="950" dirty="0"/>
+              <a:t>direct 0.612 → distil 0.741</a:t>
+            </a:r>
+            <a:endParaRPr lang="en-US" sz="1100" dirty="0"/>
           </a:p>
         </p:txBody>
       </p:sp>

</xml_diff>